<commit_message>
Slide 3: present the tools as standalone, drop the composition framing
Replaces the 'they compose / output feeds input' bullet and the pipeline
flow graphic with an 'each stands alone' bullet: pick whichever tool
answers today's question; the shared servers.txt format and verbs are a
convenience, not a dependency. The run-order flow now appears only on
the closing 'Putting it together' slide.

Co-Authored-By: Claude Opus 5 <noreply@anthropic.com>
Claude-Session: https://claude.ai/code/session_01YPt3NpH6cm292hY2d8Gi5v
</commit_message>
<xml_diff>
--- a/network-testing/network_testing.pptx
+++ b/network-testing/network_testing.pptx
@@ -1306,7 +1306,7 @@
           <a:lstStyle/>
           <a:p>
             <a:r>
-              <a:t>The alternative is a week of hand-run iperf, ad-hoc pssh loops, and numbers nobody trusts. Spell out "they compose" plainly: one server list drives everything, and the outputs are designed to sit next to each other — pruning the list, baselining, then loading is a chain of commands, not three integrations. The pipeline on the slide is the whole talk in one line; the three big sections that follow just walk it left to right.</a:t>
+              <a:t>The alternative is a week of hand-run iperf, ad-hoc pssh loops, and numbers nobody trusts. Each tool is complete on its own — grab the one that matches the question in front of you. The shared conventions are a convenience, not a dependency: one servers.txt works everywhere, and the gen / start / status / summarize / stop / clean verbs mean the muscle memory transfers.</a:t>
             </a:r>
           </a:p>
         </p:txBody>
@@ -10054,627 +10054,57 @@
               </a:defRPr>
             </a:pPr>
             <a:r>
-              <a:t>Why these tools — and how they fit together</a:t>
-            </a:r>
-          </a:p>
-        </p:txBody>
-      </p:sp>
-      <p:sp>
-        <p:nvSpPr>
-          <p:cNvPr id="3" name="TextBox 2"/>
-          <p:cNvSpPr txBox="1"/>
-          <p:nvPr/>
-        </p:nvSpPr>
-        <p:spPr>
-          <a:xfrm>
-            <a:off x="822960" y="1234440"/>
-            <a:ext cx="10607040" cy="621792"/>
-          </a:xfrm>
-          <a:prstGeom prst="rect">
-            <a:avLst/>
-          </a:prstGeom>
-          <a:noFill/>
-        </p:spPr>
+              <a:t>Why these tools</a:t>
+            </a:r>
+          </a:p>
+        </p:txBody>
+      </p:sp>
+      <p:sp>
+        <p:nvSpPr>
+          <p:cNvPr id="3" name="Content Placeholder 2"/>
+          <p:cNvSpPr>
+            <a:spLocks noGrp="1"/>
+          </p:cNvSpPr>
+          <p:nvPr>
+            <p:ph idx="1"/>
+          </p:nvPr>
+        </p:nvSpPr>
+        <p:spPr/>
         <p:txBody>
           <a:bodyPr wrap="square">
-            <a:spAutoFit/>
+            <a:normAutofit/>
           </a:bodyPr>
           <a:lstStyle/>
           <a:p>
             <a:pPr>
-              <a:defRPr sz="1400"/>
-            </a:pPr>
-            <a:r>
-              <a:t>• They go anywhere you can ssh. No agents, no daemons, no root — nothing installed on the servers, and clean removes every trace afterwards.</a:t>
-            </a:r>
-          </a:p>
-        </p:txBody>
-      </p:sp>
-      <p:sp>
-        <p:nvSpPr>
-          <p:cNvPr id="4" name="TextBox 3"/>
-          <p:cNvSpPr txBox="1"/>
-          <p:nvPr/>
-        </p:nvSpPr>
-        <p:spPr>
-          <a:xfrm>
-            <a:off x="822960" y="1929384"/>
-            <a:ext cx="10607040" cy="621792"/>
-          </a:xfrm>
-          <a:prstGeom prst="rect">
-            <a:avLst/>
-          </a:prstGeom>
-          <a:noFill/>
-        </p:spPr>
-        <p:txBody>
-          <a:bodyPr wrap="square">
-            <a:spAutoFit/>
-          </a:bodyPr>
-          <a:lstStyle/>
-          <a:p>
-            <a:pPr>
-              <a:defRPr sz="1400"/>
-            </a:pPr>
-            <a:r>
-              <a:t>• The numbers are honest. Blank never means zero, and the headline is what the *receiver* counted — not what the sender hoped. When a tool becomes its own bottleneck, it says so.</a:t>
-            </a:r>
-          </a:p>
-        </p:txBody>
-      </p:sp>
-      <p:sp>
-        <p:nvSpPr>
-          <p:cNvPr id="5" name="TextBox 4"/>
-          <p:cNvSpPr txBox="1"/>
-          <p:nvPr/>
-        </p:nvSpPr>
-        <p:spPr>
-          <a:xfrm>
-            <a:off x="822960" y="2624328"/>
-            <a:ext cx="10607040" cy="310896"/>
-          </a:xfrm>
-          <a:prstGeom prst="rect">
-            <a:avLst/>
-          </a:prstGeom>
-          <a:noFill/>
-        </p:spPr>
-        <p:txBody>
-          <a:bodyPr wrap="square">
-            <a:spAutoFit/>
-          </a:bodyPr>
-          <a:lstStyle/>
-          <a:p>
-            <a:pPr>
-              <a:defRPr sz="1400"/>
-            </a:pPr>
-            <a:r>
-              <a:t>• They're one file each. Stdlib-only Python — pip install it, or just scp the file and run it.</a:t>
-            </a:r>
-          </a:p>
-        </p:txBody>
-      </p:sp>
-      <p:sp>
-        <p:nvSpPr>
-          <p:cNvPr id="6" name="TextBox 5"/>
-          <p:cNvSpPr txBox="1"/>
-          <p:nvPr/>
-        </p:nvSpPr>
-        <p:spPr>
-          <a:xfrm>
-            <a:off x="822960" y="3008376"/>
-            <a:ext cx="10607040" cy="932688"/>
-          </a:xfrm>
-          <a:prstGeom prst="rect">
-            <a:avLst/>
-          </a:prstGeom>
-          <a:noFill/>
-        </p:spPr>
-        <p:txBody>
-          <a:bodyPr wrap="square">
-            <a:spAutoFit/>
-          </a:bodyPr>
-          <a:lstStyle/>
-          <a:p>
-            <a:pPr>
-              <a:defRPr sz="1400"/>
-            </a:pPr>
-            <a:r>
-              <a:t>• They compose — meaning each one's output is the next one's input. reachable rewrites the very servers.txt the others read; netmesh and mx write matching N×N grids that open side by side in one spreadsheet. You chain them; there's no glue to write.</a:t>
-            </a:r>
-          </a:p>
-        </p:txBody>
-      </p:sp>
-      <p:sp>
-        <p:nvSpPr>
-          <p:cNvPr id="7" name="Rounded Rectangle 6"/>
-          <p:cNvSpPr/>
-          <p:nvPr/>
-        </p:nvSpPr>
-        <p:spPr>
-          <a:xfrm>
-            <a:off x="640080" y="4014216"/>
-            <a:ext cx="1887321" cy="914400"/>
-          </a:xfrm>
-          <a:prstGeom prst="roundRect">
-            <a:avLst/>
-          </a:prstGeom>
-          <a:solidFill>
-            <a:srgbClr val="3D8B4F"/>
-          </a:solidFill>
-          <a:ln>
-            <a:noFill/>
-          </a:ln>
-        </p:spPr>
-        <p:style>
-          <a:lnRef idx="1">
-            <a:schemeClr val="accent1"/>
-          </a:lnRef>
-          <a:fillRef idx="3">
-            <a:schemeClr val="accent1"/>
-          </a:fillRef>
-          <a:effectRef idx="2">
-            <a:schemeClr val="accent1"/>
-          </a:effectRef>
-          <a:fontRef idx="minor">
-            <a:schemeClr val="lt1"/>
-          </a:fontRef>
-        </p:style>
-        <p:txBody>
-          <a:bodyPr rtlCol="0" anchor="ctr" wrap="square"/>
-          <a:lstStyle/>
-          <a:p>
-            <a:pPr algn="ctr">
-              <a:defRPr sz="1150" b="1">
-                <a:solidFill>
-                  <a:srgbClr val="FFFFFF"/>
-                </a:solidFill>
-                <a:latin typeface="Consolas"/>
-              </a:defRPr>
-            </a:pPr>
-            <a:r>
-              <a:t>reachable prod.txt -i</a:t>
-            </a:r>
-          </a:p>
-          <a:p>
-            <a:pPr>
-              <a:defRPr sz="1000">
-                <a:solidFill>
-                  <a:srgbClr val="F0F3F6"/>
-                </a:solidFill>
-              </a:defRPr>
-            </a:pPr>
-            <a:r>
-              <a:t>prune the list</a:t>
-            </a:r>
-          </a:p>
-        </p:txBody>
-      </p:sp>
-      <p:sp>
-        <p:nvSpPr>
-          <p:cNvPr id="8" name="TextBox 7"/>
-          <p:cNvSpPr txBox="1"/>
-          <p:nvPr/>
-        </p:nvSpPr>
-        <p:spPr>
-          <a:xfrm>
-            <a:off x="2527401" y="4270248"/>
-            <a:ext cx="384048" cy="365760"/>
-          </a:xfrm>
-          <a:prstGeom prst="rect">
-            <a:avLst/>
-          </a:prstGeom>
-          <a:noFill/>
-        </p:spPr>
-        <p:txBody>
-          <a:bodyPr wrap="none">
-            <a:spAutoFit/>
-          </a:bodyPr>
-          <a:lstStyle/>
-          <a:p>
-            <a:pPr>
-              <a:defRPr sz="1600" b="1">
-                <a:solidFill>
-                  <a:srgbClr val="3E5C76"/>
-                </a:solidFill>
-              </a:defRPr>
-            </a:pPr>
-            <a:r>
-              <a:t>→</a:t>
-            </a:r>
-          </a:p>
-        </p:txBody>
-      </p:sp>
-      <p:sp>
-        <p:nvSpPr>
-          <p:cNvPr id="9" name="Rounded Rectangle 8"/>
-          <p:cNvSpPr/>
-          <p:nvPr/>
-        </p:nvSpPr>
-        <p:spPr>
-          <a:xfrm>
-            <a:off x="2911449" y="4014216"/>
-            <a:ext cx="1887321" cy="914400"/>
-          </a:xfrm>
-          <a:prstGeom prst="roundRect">
-            <a:avLst/>
-          </a:prstGeom>
-          <a:solidFill>
-            <a:srgbClr val="12897B"/>
-          </a:solidFill>
-          <a:ln>
-            <a:noFill/>
-          </a:ln>
-        </p:spPr>
-        <p:style>
-          <a:lnRef idx="1">
-            <a:schemeClr val="accent1"/>
-          </a:lnRef>
-          <a:fillRef idx="3">
-            <a:schemeClr val="accent1"/>
-          </a:fillRef>
-          <a:effectRef idx="2">
-            <a:schemeClr val="accent1"/>
-          </a:effectRef>
-          <a:fontRef idx="minor">
-            <a:schemeClr val="lt1"/>
-          </a:fontRef>
-        </p:style>
-        <p:txBody>
-          <a:bodyPr rtlCol="0" anchor="ctr" wrap="square"/>
-          <a:lstStyle/>
-          <a:p>
-            <a:pPr algn="ctr">
-              <a:defRPr sz="1150" b="1">
-                <a:solidFill>
-                  <a:srgbClr val="FFFFFF"/>
-                </a:solidFill>
-                <a:latin typeface="Consolas"/>
-              </a:defRPr>
-            </a:pPr>
-            <a:r>
-              <a:t>netmesh check</a:t>
-            </a:r>
-          </a:p>
-          <a:p>
-            <a:pPr>
-              <a:defRPr sz="1000">
-                <a:solidFill>
-                  <a:srgbClr val="F0F3F6"/>
-                </a:solidFill>
-              </a:defRPr>
-            </a:pPr>
-            <a:r>
-              <a:t>idle baseline</a:t>
-            </a:r>
-          </a:p>
-        </p:txBody>
-      </p:sp>
-      <p:sp>
-        <p:nvSpPr>
-          <p:cNvPr id="10" name="TextBox 9"/>
-          <p:cNvSpPr txBox="1"/>
-          <p:nvPr/>
-        </p:nvSpPr>
-        <p:spPr>
-          <a:xfrm>
-            <a:off x="4798771" y="4270248"/>
-            <a:ext cx="384048" cy="365760"/>
-          </a:xfrm>
-          <a:prstGeom prst="rect">
-            <a:avLst/>
-          </a:prstGeom>
-          <a:noFill/>
-        </p:spPr>
-        <p:txBody>
-          <a:bodyPr wrap="none">
-            <a:spAutoFit/>
-          </a:bodyPr>
-          <a:lstStyle/>
-          <a:p>
-            <a:pPr>
-              <a:defRPr sz="1600" b="1">
-                <a:solidFill>
-                  <a:srgbClr val="3E5C76"/>
-                </a:solidFill>
-              </a:defRPr>
-            </a:pPr>
-            <a:r>
-              <a:t>→</a:t>
-            </a:r>
-          </a:p>
-        </p:txBody>
-      </p:sp>
-      <p:sp>
-        <p:nvSpPr>
-          <p:cNvPr id="11" name="Rounded Rectangle 10"/>
-          <p:cNvSpPr/>
-          <p:nvPr/>
-        </p:nvSpPr>
-        <p:spPr>
-          <a:xfrm>
-            <a:off x="5182819" y="4014216"/>
-            <a:ext cx="1887321" cy="914400"/>
-          </a:xfrm>
-          <a:prstGeom prst="roundRect">
-            <a:avLst/>
-          </a:prstGeom>
-          <a:solidFill>
-            <a:srgbClr val="D97C1F"/>
-          </a:solidFill>
-          <a:ln>
-            <a:noFill/>
-          </a:ln>
-        </p:spPr>
-        <p:style>
-          <a:lnRef idx="1">
-            <a:schemeClr val="accent1"/>
-          </a:lnRef>
-          <a:fillRef idx="3">
-            <a:schemeClr val="accent1"/>
-          </a:fillRef>
-          <a:effectRef idx="2">
-            <a:schemeClr val="accent1"/>
-          </a:effectRef>
-          <a:fontRef idx="minor">
-            <a:schemeClr val="lt1"/>
-          </a:fontRef>
-        </p:style>
-        <p:txBody>
-          <a:bodyPr rtlCol="0" anchor="ctr" wrap="square"/>
-          <a:lstStyle/>
-          <a:p>
-            <a:pPr algn="ctr">
-              <a:defRPr sz="1150" b="1">
-                <a:solidFill>
-                  <a:srgbClr val="FFFFFF"/>
-                </a:solidFill>
-                <a:latin typeface="Consolas"/>
-              </a:defRPr>
-            </a:pPr>
-            <a:r>
-              <a:t>iperf-orchestrator all</a:t>
-            </a:r>
-          </a:p>
-          <a:p>
-            <a:pPr>
-              <a:defRPr sz="1000">
-                <a:solidFill>
-                  <a:srgbClr val="F0F3F6"/>
-                </a:solidFill>
-              </a:defRPr>
-            </a:pPr>
-            <a:r>
-              <a:t>TCP under load</a:t>
-            </a:r>
-          </a:p>
-        </p:txBody>
-      </p:sp>
-      <p:sp>
-        <p:nvSpPr>
-          <p:cNvPr id="12" name="TextBox 11"/>
-          <p:cNvSpPr txBox="1"/>
-          <p:nvPr/>
-        </p:nvSpPr>
-        <p:spPr>
-          <a:xfrm>
-            <a:off x="7070140" y="4270248"/>
-            <a:ext cx="384048" cy="365760"/>
-          </a:xfrm>
-          <a:prstGeom prst="rect">
-            <a:avLst/>
-          </a:prstGeom>
-          <a:noFill/>
-        </p:spPr>
-        <p:txBody>
-          <a:bodyPr wrap="none">
-            <a:spAutoFit/>
-          </a:bodyPr>
-          <a:lstStyle/>
-          <a:p>
-            <a:pPr>
-              <a:defRPr sz="1600" b="1">
-                <a:solidFill>
-                  <a:srgbClr val="3E5C76"/>
-                </a:solidFill>
-              </a:defRPr>
-            </a:pPr>
-            <a:r>
-              <a:t>→</a:t>
-            </a:r>
-          </a:p>
-        </p:txBody>
-      </p:sp>
-      <p:sp>
-        <p:nvSpPr>
-          <p:cNvPr id="13" name="Rounded Rectangle 12"/>
-          <p:cNvSpPr/>
-          <p:nvPr/>
-        </p:nvSpPr>
-        <p:spPr>
-          <a:xfrm>
-            <a:off x="7454188" y="4014216"/>
-            <a:ext cx="1887321" cy="914400"/>
-          </a:xfrm>
-          <a:prstGeom prst="roundRect">
-            <a:avLst/>
-          </a:prstGeom>
-          <a:solidFill>
-            <a:srgbClr val="BE3B4E"/>
-          </a:solidFill>
-          <a:ln>
-            <a:noFill/>
-          </a:ln>
-        </p:spPr>
-        <p:style>
-          <a:lnRef idx="1">
-            <a:schemeClr val="accent1"/>
-          </a:lnRef>
-          <a:fillRef idx="3">
-            <a:schemeClr val="accent1"/>
-          </a:fillRef>
-          <a:effectRef idx="2">
-            <a:schemeClr val="accent1"/>
-          </a:effectRef>
-          <a:fontRef idx="minor">
-            <a:schemeClr val="lt1"/>
-          </a:fontRef>
-        </p:style>
-        <p:txBody>
-          <a:bodyPr rtlCol="0" anchor="ctr" wrap="square"/>
-          <a:lstStyle/>
-          <a:p>
-            <a:pPr algn="ctr">
-              <a:defRPr sz="1150" b="1">
-                <a:solidFill>
-                  <a:srgbClr val="FFFFFF"/>
-                </a:solidFill>
-                <a:latin typeface="Consolas"/>
-              </a:defRPr>
-            </a:pPr>
-            <a:r>
-              <a:t>mx run</a:t>
-            </a:r>
-          </a:p>
-          <a:p>
-            <a:pPr>
-              <a:defRPr sz="1000">
-                <a:solidFill>
-                  <a:srgbClr val="F0F3F6"/>
-                </a:solidFill>
-              </a:defRPr>
-            </a:pPr>
-            <a:r>
-              <a:t>pps under load</a:t>
-            </a:r>
-          </a:p>
-        </p:txBody>
-      </p:sp>
-      <p:sp>
-        <p:nvSpPr>
-          <p:cNvPr id="14" name="TextBox 13"/>
-          <p:cNvSpPr txBox="1"/>
-          <p:nvPr/>
-        </p:nvSpPr>
-        <p:spPr>
-          <a:xfrm>
-            <a:off x="9341510" y="4270248"/>
-            <a:ext cx="384048" cy="365760"/>
-          </a:xfrm>
-          <a:prstGeom prst="rect">
-            <a:avLst/>
-          </a:prstGeom>
-          <a:noFill/>
-        </p:spPr>
-        <p:txBody>
-          <a:bodyPr wrap="none">
-            <a:spAutoFit/>
-          </a:bodyPr>
-          <a:lstStyle/>
-          <a:p>
-            <a:pPr>
-              <a:defRPr sz="1600" b="1">
-                <a:solidFill>
-                  <a:srgbClr val="3E5C76"/>
-                </a:solidFill>
-              </a:defRPr>
-            </a:pPr>
-            <a:r>
-              <a:t>→</a:t>
-            </a:r>
-          </a:p>
-        </p:txBody>
-      </p:sp>
-      <p:sp>
-        <p:nvSpPr>
-          <p:cNvPr id="15" name="Rounded Rectangle 14"/>
-          <p:cNvSpPr/>
-          <p:nvPr/>
-        </p:nvSpPr>
-        <p:spPr>
-          <a:xfrm>
-            <a:off x="9725558" y="4014216"/>
-            <a:ext cx="1887321" cy="914400"/>
-          </a:xfrm>
-          <a:prstGeom prst="roundRect">
-            <a:avLst/>
-          </a:prstGeom>
-          <a:solidFill>
-            <a:srgbClr val="12897B"/>
-          </a:solidFill>
-          <a:ln>
-            <a:noFill/>
-          </a:ln>
-        </p:spPr>
-        <p:style>
-          <a:lnRef idx="1">
-            <a:schemeClr val="accent1"/>
-          </a:lnRef>
-          <a:fillRef idx="3">
-            <a:schemeClr val="accent1"/>
-          </a:fillRef>
-          <a:effectRef idx="2">
-            <a:schemeClr val="accent1"/>
-          </a:effectRef>
-          <a:fontRef idx="minor">
-            <a:schemeClr val="lt1"/>
-          </a:fontRef>
-        </p:style>
-        <p:txBody>
-          <a:bodyPr rtlCol="0" anchor="ctr" wrap="square"/>
-          <a:lstStyle/>
-          <a:p>
-            <a:pPr algn="ctr">
-              <a:defRPr sz="1150" b="1">
-                <a:solidFill>
-                  <a:srgbClr val="FFFFFF"/>
-                </a:solidFill>
-                <a:latin typeface="Consolas"/>
-              </a:defRPr>
-            </a:pPr>
-            <a:r>
-              <a:t>netmesh --baseline</a:t>
-            </a:r>
-          </a:p>
-          <a:p>
-            <a:pPr>
-              <a:defRPr sz="1000">
-                <a:solidFill>
-                  <a:srgbClr val="F0F3F6"/>
-                </a:solidFill>
-              </a:defRPr>
-            </a:pPr>
-            <a:r>
-              <a:t>latency under load</a:t>
-            </a:r>
-          </a:p>
-        </p:txBody>
-      </p:sp>
-      <p:sp>
-        <p:nvSpPr>
-          <p:cNvPr id="16" name="TextBox 15"/>
-          <p:cNvSpPr txBox="1"/>
-          <p:nvPr/>
-        </p:nvSpPr>
-        <p:spPr>
-          <a:xfrm>
-            <a:off x="822960" y="5129784"/>
-            <a:ext cx="10607040" cy="621792"/>
-          </a:xfrm>
-          <a:prstGeom prst="rect">
-            <a:avLst/>
-          </a:prstGeom>
-          <a:noFill/>
-        </p:spPr>
-        <p:txBody>
-          <a:bodyPr wrap="square">
-            <a:spAutoFit/>
-          </a:bodyPr>
-          <a:lstStyle/>
-          <a:p>
-            <a:pPr>
-              <a:defRPr sz="1400"/>
-            </a:pPr>
-            <a:r>
-              <a:t>Commissioning a new fabric? Run them left to right — each answer tells you whether the next number will make sense.</a:t>
+              <a:defRPr sz="1600"/>
+            </a:pPr>
+            <a:r>
+              <a:t>They go anywhere you can ssh. No agents, no daemons, no root — nothing installed on the servers, and clean removes every trace afterwards.</a:t>
+            </a:r>
+          </a:p>
+          <a:p>
+            <a:pPr>
+              <a:defRPr sz="1600"/>
+            </a:pPr>
+            <a:r>
+              <a:t>The numbers are honest. Blank never means zero, and the headline is what the *receiver* counted — not what the sender hoped. When a tool becomes its own bottleneck, it says so.</a:t>
+            </a:r>
+          </a:p>
+          <a:p>
+            <a:pPr>
+              <a:defRPr sz="1600"/>
+            </a:pPr>
+            <a:r>
+              <a:t>They're one file each. Stdlib-only Python — pip install it, or just scp the file and run it.</a:t>
+            </a:r>
+          </a:p>
+          <a:p>
+            <a:pPr>
+              <a:defRPr sz="1600"/>
+            </a:pPr>
+            <a:r>
+              <a:t>Each stands alone. Pick whichever answers today's question — no setup or ordering ties them together. They do share the same server-list format and the same verbs, so learning one means you can drive them all.</a:t>
             </a:r>
           </a:p>
         </p:txBody>

</xml_diff>